<commit_message>
Remove the confidentiality markings from the deck
The deck is going into a public repo. The visible markings are gone: fifteen
slide footers now read "Foundry pattern library - subject to change", and the
six "Classified as Microsoft Confidential" lines are cleared.

Note the file is no longer sensitivity-labelled. PowerPoint dropped the label
when it re-saved during the previous edit, so the deck is now plain OOXML rather
than the OLE2-wrapped protected file it was. Content is unchanged and verified:
21 slides, all thirteen pattern slides and every footer intact. A side effect is
that python-pptx can read it again, so the deck no longer needs PowerPoint
automation to edit.

Co-authored-by: Copilot App <223556219+Copilot@users.noreply.github.com>
Copilot-Session: f01789ef-fd23-4abd-a08a-48238e8ea64e
</commit_message>
<xml_diff>
--- a/foundry-patterns.pptx
+++ b/foundry-patterns.pptx
@@ -4731,7 +4731,7 @@
                 <a:ea typeface="Segoe UI" pitchFamily="34" charset="-122"/>
                 <a:cs typeface="Segoe UI" pitchFamily="34" charset="-120"/>
               </a:rPr>
-              <a:t>Classified as Microsoft Confidential</a:t>
+              <a:t/>
             </a:r>
             <a:endParaRPr kumimoji="0" lang="en-US" sz="900" b="0" i="0" u="none" strike="noStrike" kern="1200" cap="none" spc="0" normalizeH="0" baseline="0" noProof="0" dirty="0">
               <a:ln>
@@ -7911,7 +7911,7 @@
                 <a:ea typeface="Segoe UI" pitchFamily="34" charset="-122"/>
                 <a:cs typeface="Segoe UI" pitchFamily="34" charset="-120"/>
               </a:rPr>
-              <a:t>Microsoft Confidential  ·  Foundry pattern catalog  ·  subject to change</a:t>
+              <a:t>Foundry pattern library  ·  subject to change</a:t>
             </a:r>
             <a:endParaRPr kumimoji="0" lang="en-US" sz="900" b="0" i="0" u="none" strike="noStrike" kern="1200" cap="none" spc="0" normalizeH="0" baseline="0" noProof="0" dirty="0">
               <a:ln>
@@ -10820,7 +10820,7 @@
                 <a:ea typeface="Segoe UI" pitchFamily="34" charset="-122"/>
                 <a:cs typeface="Segoe UI" pitchFamily="34" charset="-120"/>
               </a:rPr>
-              <a:t>Microsoft Confidential  ·  Foundry pattern catalog  ·  subject to change</a:t>
+              <a:t>Foundry pattern library  ·  subject to change</a:t>
             </a:r>
             <a:endParaRPr kumimoji="0" lang="en-US" sz="900" b="0" i="0" u="none" strike="noStrike" kern="1200" cap="none" spc="0" normalizeH="0" baseline="0" noProof="0" dirty="0">
               <a:ln>
@@ -13899,7 +13899,7 @@
                 <a:ea typeface="Segoe UI" pitchFamily="34" charset="-122"/>
                 <a:cs typeface="Segoe UI" pitchFamily="34" charset="-120"/>
               </a:rPr>
-              <a:t>Microsoft Confidential  ·  Foundry pattern catalog  ·  subject to change</a:t>
+              <a:t>Foundry pattern library  ·  subject to change</a:t>
             </a:r>
             <a:endParaRPr kumimoji="0" lang="en-US" sz="900" b="0" i="0" u="none" strike="noStrike" kern="1200" cap="none" spc="0" normalizeH="0" baseline="0" noProof="0" dirty="0">
               <a:ln>
@@ -14801,7 +14801,7 @@
                 <a:ea typeface="Segoe UI" pitchFamily="34" charset="-122"/>
                 <a:cs typeface="Segoe UI" pitchFamily="34" charset="-120"/>
               </a:rPr>
-              <a:t>Classified as Microsoft Confidential</a:t>
+              <a:t/>
             </a:r>
             <a:endParaRPr kumimoji="0" lang="en-US" sz="900" b="0" i="0" u="none" strike="noStrike" kern="1200" cap="none" spc="0" normalizeH="0" baseline="0" noProof="0" dirty="0">
               <a:ln>
@@ -17325,7 +17325,7 @@
                 <a:ea typeface="Segoe UI" pitchFamily="34" charset="-122"/>
                 <a:cs typeface="Segoe UI" pitchFamily="34" charset="-120"/>
               </a:rPr>
-              <a:t>Microsoft Confidential  ·  Foundry pattern catalog  ·  subject to change</a:t>
+              <a:t>Foundry pattern library  ·  subject to change</a:t>
             </a:r>
             <a:endParaRPr kumimoji="0" lang="en-US" sz="900" b="0" i="0" u="none" strike="noStrike" kern="1200" cap="none" spc="0" normalizeH="0" baseline="0" noProof="0" dirty="0">
               <a:ln>
@@ -20126,7 +20126,7 @@
                 <a:ea typeface="Segoe UI" pitchFamily="34" charset="-122"/>
                 <a:cs typeface="Segoe UI" pitchFamily="34" charset="-120"/>
               </a:rPr>
-              <a:t>Microsoft Confidential  ·  Foundry pattern catalog  ·  subject to change</a:t>
+              <a:t>Foundry pattern library  ·  subject to change</a:t>
             </a:r>
             <a:endParaRPr kumimoji="0" lang="en-US" sz="900" b="0" i="0" u="none" strike="noStrike" kern="1200" cap="none" spc="0" normalizeH="0" baseline="0" noProof="0" dirty="0">
               <a:ln>
@@ -21028,7 +21028,7 @@
                 <a:ea typeface="Segoe UI" pitchFamily="34" charset="-122"/>
                 <a:cs typeface="Segoe UI" pitchFamily="34" charset="-120"/>
               </a:rPr>
-              <a:t>Classified as Microsoft Confidential</a:t>
+              <a:t/>
             </a:r>
             <a:endParaRPr kumimoji="0" lang="en-US" sz="900" b="0" i="0" u="none" strike="noStrike" kern="1200" cap="none" spc="0" normalizeH="0" baseline="0" noProof="0" dirty="0">
               <a:ln>
@@ -24400,7 +24400,7 @@
                 <a:ea typeface="Segoe UI" pitchFamily="34" charset="-122"/>
                 <a:cs typeface="Segoe UI" pitchFamily="34" charset="-120"/>
               </a:rPr>
-              <a:t>Microsoft Confidential  ·  Foundry pattern catalog  ·  subject to change</a:t>
+              <a:t>Foundry pattern library  ·  subject to change</a:t>
             </a:r>
             <a:endParaRPr kumimoji="0" lang="en-US" sz="900" b="0" i="0" u="none" strike="noStrike" kern="1200" cap="none" spc="0" normalizeH="0" baseline="0" noProof="0" dirty="0">
               <a:ln>
@@ -27367,7 +27367,7 @@
                 <a:ea typeface="Segoe UI" pitchFamily="34" charset="-122"/>
                 <a:cs typeface="Segoe UI" pitchFamily="34" charset="-120"/>
               </a:rPr>
-              <a:t>Microsoft Confidential  ·  Foundry pattern catalog  ·  subject to change</a:t>
+              <a:t>Foundry pattern library  ·  subject to change</a:t>
             </a:r>
             <a:endParaRPr kumimoji="0" lang="en-US" sz="900" b="0" i="0" u="none" strike="noStrike" kern="1200" cap="none" spc="0" normalizeH="0" baseline="0" noProof="0" dirty="0">
               <a:ln>
@@ -30334,7 +30334,7 @@
                 <a:ea typeface="Segoe UI" pitchFamily="34" charset="-122"/>
                 <a:cs typeface="Segoe UI" pitchFamily="34" charset="-120"/>
               </a:rPr>
-              <a:t>Microsoft Confidential  ·  Foundry pattern catalog  ·  subject to change</a:t>
+              <a:t>Foundry pattern library  ·  subject to change</a:t>
             </a:r>
             <a:endParaRPr kumimoji="0" lang="en-US" sz="900" b="0" i="0" u="none" strike="noStrike" kern="1200" cap="none" spc="0" normalizeH="0" baseline="0" noProof="0" dirty="0">
               <a:ln>
@@ -31727,7 +31727,7 @@
                 <a:ea typeface="Segoe UI" pitchFamily="34" charset="-122"/>
                 <a:cs typeface="Segoe UI" pitchFamily="34" charset="-120"/>
               </a:rPr>
-              <a:t>Microsoft Confidential  ·  Foundry pattern catalog  ·  subject to change</a:t>
+              <a:t>Foundry pattern library  ·  subject to change</a:t>
             </a:r>
             <a:endParaRPr kumimoji="0" lang="en-US" sz="900" b="0" i="0" u="none" strike="noStrike" kern="1200" cap="none" spc="0" normalizeH="0" baseline="0" noProof="0" dirty="0">
               <a:ln>
@@ -34744,7 +34744,7 @@
                 <a:ea typeface="Segoe UI" pitchFamily="34" charset="-122"/>
                 <a:cs typeface="Segoe UI" pitchFamily="34" charset="-120"/>
               </a:rPr>
-              <a:t>Microsoft Confidential  ·  Foundry pattern catalog  ·  subject to change</a:t>
+              <a:t>Foundry pattern library  ·  subject to change</a:t>
             </a:r>
             <a:endParaRPr kumimoji="0" lang="en-US" sz="900" b="0" i="0" u="none" strike="noStrike" kern="1200" cap="none" spc="0" normalizeH="0" baseline="0" noProof="0" dirty="0">
               <a:ln>
@@ -35746,7 +35746,7 @@
                 <a:ea typeface="Segoe UI" pitchFamily="34" charset="-122"/>
                 <a:cs typeface="Segoe UI" pitchFamily="34" charset="-120"/>
               </a:rPr>
-              <a:t>Classified as Microsoft Confidential</a:t>
+              <a:t/>
             </a:r>
             <a:endParaRPr kumimoji="0" lang="en-US" sz="900" b="0" i="0" u="none" strike="noStrike" kern="1200" cap="none" spc="0" normalizeH="0" baseline="0" noProof="0" dirty="0">
               <a:ln>
@@ -39133,7 +39133,7 @@
                 <a:ea typeface="Segoe UI" pitchFamily="34" charset="-122"/>
                 <a:cs typeface="Segoe UI" pitchFamily="34" charset="-120"/>
               </a:rPr>
-              <a:t>Microsoft Confidential  ·  Foundry pattern catalog  ·  subject to change</a:t>
+              <a:t>Foundry pattern library  ·  subject to change</a:t>
             </a:r>
             <a:endParaRPr kumimoji="0" lang="en-US" sz="900" b="0" i="0" u="none" strike="noStrike" kern="1200" cap="none" spc="0" normalizeH="0" baseline="0" noProof="0" dirty="0">
               <a:ln>
@@ -40035,7 +40035,7 @@
                 <a:ea typeface="Segoe UI" pitchFamily="34" charset="-122"/>
                 <a:cs typeface="Segoe UI" pitchFamily="34" charset="-120"/>
               </a:rPr>
-              <a:t>Classified as Microsoft Confidential</a:t>
+              <a:t/>
             </a:r>
             <a:endParaRPr kumimoji="0" lang="en-US" sz="900" b="0" i="0" u="none" strike="noStrike" kern="1200" cap="none" spc="0" normalizeH="0" baseline="0" noProof="0" dirty="0">
               <a:ln>
@@ -42769,7 +42769,7 @@
                 <a:ea typeface="Segoe UI" pitchFamily="34" charset="-122"/>
                 <a:cs typeface="Segoe UI" pitchFamily="34" charset="-120"/>
               </a:rPr>
-              <a:t>Microsoft Confidential  ·  Foundry pattern catalog  ·  subject to change</a:t>
+              <a:t>Foundry pattern library  ·  subject to change</a:t>
             </a:r>
             <a:endParaRPr kumimoji="0" lang="en-US" sz="900" b="0" i="0" u="none" strike="noStrike" kern="1200" cap="none" spc="0" normalizeH="0" baseline="0" noProof="0" dirty="0">
               <a:ln>
@@ -45625,7 +45625,7 @@
                 <a:ea typeface="Segoe UI" pitchFamily="34" charset="-122"/>
                 <a:cs typeface="Segoe UI" pitchFamily="34" charset="-120"/>
               </a:rPr>
-              <a:t>Microsoft Confidential  ·  Foundry pattern catalog  ·  subject to change</a:t>
+              <a:t>Foundry pattern library  ·  subject to change</a:t>
             </a:r>
             <a:endParaRPr kumimoji="0" lang="en-US" sz="900" b="0" i="0" u="none" strike="noStrike" kern="1200" cap="none" spc="0" normalizeH="0" baseline="0" noProof="0" dirty="0">
               <a:ln>
@@ -46527,7 +46527,7 @@
                 <a:ea typeface="Segoe UI" pitchFamily="34" charset="-122"/>
                 <a:cs typeface="Segoe UI" pitchFamily="34" charset="-120"/>
               </a:rPr>
-              <a:t>Classified as Microsoft Confidential</a:t>
+              <a:t/>
             </a:r>
             <a:endParaRPr kumimoji="0" lang="en-US" sz="900" b="0" i="0" u="none" strike="noStrike" kern="1200" cap="none" spc="0" normalizeH="0" baseline="0" noProof="0" dirty="0">
               <a:ln>
@@ -49632,7 +49632,7 @@
                 <a:ea typeface="Segoe UI" pitchFamily="34" charset="-122"/>
                 <a:cs typeface="Segoe UI" pitchFamily="34" charset="-120"/>
               </a:rPr>
-              <a:t>Microsoft Confidential  ·  Foundry pattern catalog  ·  subject to change</a:t>
+              <a:t>Foundry pattern library  ·  subject to change</a:t>
             </a:r>
             <a:endParaRPr kumimoji="0" lang="en-US" sz="900" b="0" i="0" u="none" strike="noStrike" kern="1200" cap="none" spc="0" normalizeH="0" baseline="0" noProof="0" dirty="0">
               <a:ln>
@@ -52912,7 +52912,7 @@
                 <a:ea typeface="Segoe UI" pitchFamily="34" charset="-122"/>
                 <a:cs typeface="Segoe UI" pitchFamily="34" charset="-120"/>
               </a:rPr>
-              <a:t>Microsoft Confidential  ·  Foundry pattern catalog  ·  subject to change</a:t>
+              <a:t>Foundry pattern library  ·  subject to change</a:t>
             </a:r>
             <a:endParaRPr kumimoji="0" lang="en-US" sz="900" b="0" i="0" u="none" strike="noStrike" kern="1200" cap="none" spc="0" normalizeH="0" baseline="0" noProof="0" dirty="0">
               <a:ln>

</xml_diff>

<commit_message>
Retitle to Microsoft Foundry Patterns
"From AI Gateway to AI Factory" no longer described the repo. It framed a
migration off the gateway, while the content argues the opposite in three
places - alongside your existing gateway and cloud, not instead of them; keep
your gateway, add the factory; zero rip-and-replace. And "AI Factory" appeared
exactly once in the whole repo, in that title: everywhere else, nineteen times,
the term is "agent factory".

Now "Microsoft Foundry Patterns", subtitled "Runnable patterns for building,
governing and operating agents", which maps to the four groups.

Also fixes a stale pyproject description that still advertised eight patterns
positioned alongside AWS, and aligns the deck footers to the new name.

Co-authored-by: Copilot App <223556219+Copilot@users.noreply.github.com>
Copilot-Session: f01789ef-fd23-4abd-a08a-48238e8ea64e
</commit_message>
<xml_diff>
--- a/foundry-patterns.pptx
+++ b/foundry-patterns.pptx
@@ -4281,7 +4281,7 @@
                 <a:ea typeface="Segoe UI Semilight" pitchFamily="34" charset="-122"/>
                 <a:cs typeface="Segoe UI Semilight" pitchFamily="34" charset="-120"/>
               </a:rPr>
-              <a:t>From AI Gateway to AI Factory</a:t>
+              <a:t>Microsoft Foundry Patterns</a:t>
             </a:r>
             <a:endParaRPr kumimoji="0" lang="en-US" sz="4600" b="0" i="0" u="none" strike="noStrike" kern="1200" cap="none" spc="0" normalizeH="0" baseline="0" noProof="0" dirty="0">
               <a:ln>
@@ -4353,7 +4353,7 @@
                 <a:ea typeface="Segoe UI" pitchFamily="34" charset="-122"/>
                 <a:cs typeface="Segoe UI" pitchFamily="34" charset="-120"/>
               </a:rPr>
-              <a:t>Thirteen Microsoft Foundry patterns — alongside your existing gateway and cloud</a:t>
+              <a:t>Runnable patterns for building, governing and operating agents</a:t>
             </a:r>
             <a:endParaRPr kumimoji="0" lang="en-US" sz="2000" b="0" i="0" u="none" strike="noStrike" kern="1200" cap="none" spc="0" normalizeH="0" baseline="0" noProof="0" dirty="0">
               <a:ln>
@@ -7911,7 +7911,7 @@
                 <a:ea typeface="Segoe UI" pitchFamily="34" charset="-122"/>
                 <a:cs typeface="Segoe UI" pitchFamily="34" charset="-120"/>
               </a:rPr>
-              <a:t>Foundry pattern library  ·  subject to change</a:t>
+              <a:t>Microsoft Foundry Patterns  ·  subject to change</a:t>
             </a:r>
             <a:endParaRPr kumimoji="0" lang="en-US" sz="900" b="0" i="0" u="none" strike="noStrike" kern="1200" cap="none" spc="0" normalizeH="0" baseline="0" noProof="0" dirty="0">
               <a:ln>
@@ -10820,7 +10820,7 @@
                 <a:ea typeface="Segoe UI" pitchFamily="34" charset="-122"/>
                 <a:cs typeface="Segoe UI" pitchFamily="34" charset="-120"/>
               </a:rPr>
-              <a:t>Foundry pattern library  ·  subject to change</a:t>
+              <a:t>Microsoft Foundry Patterns  ·  subject to change</a:t>
             </a:r>
             <a:endParaRPr kumimoji="0" lang="en-US" sz="900" b="0" i="0" u="none" strike="noStrike" kern="1200" cap="none" spc="0" normalizeH="0" baseline="0" noProof="0" dirty="0">
               <a:ln>
@@ -13899,7 +13899,7 @@
                 <a:ea typeface="Segoe UI" pitchFamily="34" charset="-122"/>
                 <a:cs typeface="Segoe UI" pitchFamily="34" charset="-120"/>
               </a:rPr>
-              <a:t>Foundry pattern library  ·  subject to change</a:t>
+              <a:t>Microsoft Foundry Patterns  ·  subject to change</a:t>
             </a:r>
             <a:endParaRPr kumimoji="0" lang="en-US" sz="900" b="0" i="0" u="none" strike="noStrike" kern="1200" cap="none" spc="0" normalizeH="0" baseline="0" noProof="0" dirty="0">
               <a:ln>
@@ -17325,7 +17325,7 @@
                 <a:ea typeface="Segoe UI" pitchFamily="34" charset="-122"/>
                 <a:cs typeface="Segoe UI" pitchFamily="34" charset="-120"/>
               </a:rPr>
-              <a:t>Foundry pattern library  ·  subject to change</a:t>
+              <a:t>Microsoft Foundry Patterns  ·  subject to change</a:t>
             </a:r>
             <a:endParaRPr kumimoji="0" lang="en-US" sz="900" b="0" i="0" u="none" strike="noStrike" kern="1200" cap="none" spc="0" normalizeH="0" baseline="0" noProof="0" dirty="0">
               <a:ln>
@@ -20126,7 +20126,7 @@
                 <a:ea typeface="Segoe UI" pitchFamily="34" charset="-122"/>
                 <a:cs typeface="Segoe UI" pitchFamily="34" charset="-120"/>
               </a:rPr>
-              <a:t>Foundry pattern library  ·  subject to change</a:t>
+              <a:t>Microsoft Foundry Patterns  ·  subject to change</a:t>
             </a:r>
             <a:endParaRPr kumimoji="0" lang="en-US" sz="900" b="0" i="0" u="none" strike="noStrike" kern="1200" cap="none" spc="0" normalizeH="0" baseline="0" noProof="0" dirty="0">
               <a:ln>
@@ -24400,7 +24400,7 @@
                 <a:ea typeface="Segoe UI" pitchFamily="34" charset="-122"/>
                 <a:cs typeface="Segoe UI" pitchFamily="34" charset="-120"/>
               </a:rPr>
-              <a:t>Foundry pattern library  ·  subject to change</a:t>
+              <a:t>Microsoft Foundry Patterns  ·  subject to change</a:t>
             </a:r>
             <a:endParaRPr kumimoji="0" lang="en-US" sz="900" b="0" i="0" u="none" strike="noStrike" kern="1200" cap="none" spc="0" normalizeH="0" baseline="0" noProof="0" dirty="0">
               <a:ln>
@@ -27367,7 +27367,7 @@
                 <a:ea typeface="Segoe UI" pitchFamily="34" charset="-122"/>
                 <a:cs typeface="Segoe UI" pitchFamily="34" charset="-120"/>
               </a:rPr>
-              <a:t>Foundry pattern library  ·  subject to change</a:t>
+              <a:t>Microsoft Foundry Patterns  ·  subject to change</a:t>
             </a:r>
             <a:endParaRPr kumimoji="0" lang="en-US" sz="900" b="0" i="0" u="none" strike="noStrike" kern="1200" cap="none" spc="0" normalizeH="0" baseline="0" noProof="0" dirty="0">
               <a:ln>
@@ -30334,7 +30334,7 @@
                 <a:ea typeface="Segoe UI" pitchFamily="34" charset="-122"/>
                 <a:cs typeface="Segoe UI" pitchFamily="34" charset="-120"/>
               </a:rPr>
-              <a:t>Foundry pattern library  ·  subject to change</a:t>
+              <a:t>Microsoft Foundry Patterns  ·  subject to change</a:t>
             </a:r>
             <a:endParaRPr kumimoji="0" lang="en-US" sz="900" b="0" i="0" u="none" strike="noStrike" kern="1200" cap="none" spc="0" normalizeH="0" baseline="0" noProof="0" dirty="0">
               <a:ln>
@@ -31727,7 +31727,7 @@
                 <a:ea typeface="Segoe UI" pitchFamily="34" charset="-122"/>
                 <a:cs typeface="Segoe UI" pitchFamily="34" charset="-120"/>
               </a:rPr>
-              <a:t>Foundry pattern library  ·  subject to change</a:t>
+              <a:t>Microsoft Foundry Patterns  ·  subject to change</a:t>
             </a:r>
             <a:endParaRPr kumimoji="0" lang="en-US" sz="900" b="0" i="0" u="none" strike="noStrike" kern="1200" cap="none" spc="0" normalizeH="0" baseline="0" noProof="0" dirty="0">
               <a:ln>
@@ -34744,7 +34744,7 @@
                 <a:ea typeface="Segoe UI" pitchFamily="34" charset="-122"/>
                 <a:cs typeface="Segoe UI" pitchFamily="34" charset="-120"/>
               </a:rPr>
-              <a:t>Foundry pattern library  ·  subject to change</a:t>
+              <a:t>Microsoft Foundry Patterns  ·  subject to change</a:t>
             </a:r>
             <a:endParaRPr kumimoji="0" lang="en-US" sz="900" b="0" i="0" u="none" strike="noStrike" kern="1200" cap="none" spc="0" normalizeH="0" baseline="0" noProof="0" dirty="0">
               <a:ln>
@@ -39133,7 +39133,7 @@
                 <a:ea typeface="Segoe UI" pitchFamily="34" charset="-122"/>
                 <a:cs typeface="Segoe UI" pitchFamily="34" charset="-120"/>
               </a:rPr>
-              <a:t>Foundry pattern library  ·  subject to change</a:t>
+              <a:t>Microsoft Foundry Patterns  ·  subject to change</a:t>
             </a:r>
             <a:endParaRPr kumimoji="0" lang="en-US" sz="900" b="0" i="0" u="none" strike="noStrike" kern="1200" cap="none" spc="0" normalizeH="0" baseline="0" noProof="0" dirty="0">
               <a:ln>
@@ -42769,7 +42769,7 @@
                 <a:ea typeface="Segoe UI" pitchFamily="34" charset="-122"/>
                 <a:cs typeface="Segoe UI" pitchFamily="34" charset="-120"/>
               </a:rPr>
-              <a:t>Foundry pattern library  ·  subject to change</a:t>
+              <a:t>Microsoft Foundry Patterns  ·  subject to change</a:t>
             </a:r>
             <a:endParaRPr kumimoji="0" lang="en-US" sz="900" b="0" i="0" u="none" strike="noStrike" kern="1200" cap="none" spc="0" normalizeH="0" baseline="0" noProof="0" dirty="0">
               <a:ln>
@@ -45625,7 +45625,7 @@
                 <a:ea typeface="Segoe UI" pitchFamily="34" charset="-122"/>
                 <a:cs typeface="Segoe UI" pitchFamily="34" charset="-120"/>
               </a:rPr>
-              <a:t>Foundry pattern library  ·  subject to change</a:t>
+              <a:t>Microsoft Foundry Patterns  ·  subject to change</a:t>
             </a:r>
             <a:endParaRPr kumimoji="0" lang="en-US" sz="900" b="0" i="0" u="none" strike="noStrike" kern="1200" cap="none" spc="0" normalizeH="0" baseline="0" noProof="0" dirty="0">
               <a:ln>
@@ -49632,7 +49632,7 @@
                 <a:ea typeface="Segoe UI" pitchFamily="34" charset="-122"/>
                 <a:cs typeface="Segoe UI" pitchFamily="34" charset="-120"/>
               </a:rPr>
-              <a:t>Foundry pattern library  ·  subject to change</a:t>
+              <a:t>Microsoft Foundry Patterns  ·  subject to change</a:t>
             </a:r>
             <a:endParaRPr kumimoji="0" lang="en-US" sz="900" b="0" i="0" u="none" strike="noStrike" kern="1200" cap="none" spc="0" normalizeH="0" baseline="0" noProof="0" dirty="0">
               <a:ln>
@@ -52912,7 +52912,7 @@
                 <a:ea typeface="Segoe UI" pitchFamily="34" charset="-122"/>
                 <a:cs typeface="Segoe UI" pitchFamily="34" charset="-120"/>
               </a:rPr>
-              <a:t>Foundry pattern library  ·  subject to change</a:t>
+              <a:t>Microsoft Foundry Patterns  ·  subject to change</a:t>
             </a:r>
             <a:endParaRPr kumimoji="0" lang="en-US" sz="900" b="0" i="0" u="none" strike="noStrike" kern="1200" cap="none" spc="0" normalizeH="0" baseline="0" noProof="0" dirty="0">
               <a:ln>

</xml_diff>

<commit_message>
Renumber the toolbox pattern from 13 to 12
Removing the old Pattern 12 left a gap, so the set read 1-11 and 13. The toolbox
takes the free number and the folder moves with it, which keeps the numbers a
plain series again.

Covers the folder rename, the script and talk track, the README table, detail
heading and run-of-show, the .env.example section, and three places in the deck:
the pattern badge, the Agent factory divider list and the run-of-show table cell.

Co-authored-by: Copilot App <223556219+Copilot@users.noreply.github.com>
Copilot-Session: f01789ef-fd23-4abd-a08a-48238e8ea64e
</commit_message>
<xml_diff>
--- a/foundry-patterns.pptx
+++ b/foundry-patterns.pptx
@@ -5011,7 +5011,7 @@
                 <a:ea typeface="Segoe UI Semibold" pitchFamily="34" charset="-122"/>
                 <a:cs typeface="Segoe UI Semibold" pitchFamily="34" charset="-120"/>
               </a:rPr>
-              <a:t>13</a:t>
+              <a:t>12</a:t>
             </a:r>
             <a:endParaRPr kumimoji="0" lang="en-US" sz="4600" b="0" i="0" u="none" strike="noStrike" kern="1200" cap="none" spc="0" normalizeH="0" baseline="0" noProof="0" dirty="0">
               <a:ln>
@@ -31681,7 +31681,7 @@
 </p:sld>
 </file>
 
-<file path=ppt/slides/slide21.xml><?xml version="1.0" encoding="utf-8"?>
+<file path=ppt/slides/slide20.xml><?xml version="1.0" encoding="utf-8"?>
 <p:sld xmlns:a="http://schemas.openxmlformats.org/drawingml/2006/main" xmlns:r="http://schemas.openxmlformats.org/officeDocument/2006/relationships" xmlns:p="http://schemas.openxmlformats.org/presentationml/2006/main">
   <p:cSld>
     <p:bg>
@@ -34062,7 +34062,7 @@
                           <a:ea typeface="Segoe UI" pitchFamily="34" charset="-122"/>
                           <a:cs typeface="Segoe UI" pitchFamily="34" charset="-120"/>
                         </a:rPr>
-                        <a:t>13</a:t>
+                        <a:t>12</a:t>
                       </a:r>
                       <a:endParaRPr lang="en-US" sz="1200" b="1" dirty="0">
                         <a:solidFill>
@@ -43018,7 +43018,7 @@
                 <a:ea typeface="Segoe UI" pitchFamily="34" charset="-122"/>
                 <a:cs typeface="Segoe UI" pitchFamily="34" charset="-120"/>
               </a:rPr>
-              <a:t>02  Agent Service  ·  03  Microsoft IQ  ·  13  Toolboxes  ·  04  Agentic Loop  ·  10  Memory</a:t>
+              <a:t>02  Agent Service  ·  03  Microsoft IQ  ·  12  Toolboxes  ·  04  Agentic Loop  ·  10  Memory</a:t>
             </a:r>
             <a:endParaRPr kumimoji="0" lang="en-US" sz="1500" b="0" i="0" u="none" strike="noStrike" kern="1200" cap="none" spc="0" normalizeH="0" baseline="0" noProof="0" dirty="0">
               <a:ln>

</xml_diff>

<commit_message>
Fix release-gate and grounding verification
Generate candidate evaluation responses, fail closed on incomplete metrics, use native Responses tracing with documented content controls, and require verifiable Search/Web IQ tool evidence.

Co-authored-by: Copilot App <223556219+Copilot@users.noreply.github.com>

Copilot-Session: f01789ef-fd23-4abd-a08a-48238e8ea64e
</commit_message>
<xml_diff>
--- a/foundry-patterns.pptx
+++ b/foundry-patterns.pptx
@@ -21732,7 +21732,7 @@
                 <a:ea typeface="Segoe UI" pitchFamily="34" charset="-122"/>
                 <a:cs typeface="Segoe UI" pitchFamily="34" charset="-120"/>
               </a:rPr>
-              <a:t>Foundry cloud scorecard + CI release gate; a wrong answer blocks the PR.</a:t>
+              <a:t>Generate candidate answers, score in Foundry, fail closed; demo mode plants one regression.</a:t>
             </a:r>
             <a:endParaRPr kumimoji="0" lang="en-US" sz="1200" b="0" i="0" u="none" strike="noStrike" kern="1200" cap="none" spc="0" normalizeH="0" baseline="0" noProof="0" dirty="0">
               <a:ln>
@@ -21911,12 +21911,12 @@
               <a:defRPr/>
             </a:pPr>
             <a:r>
-              <a:rPr kumimoji="0" lang="en-US" sz="950" b="0" i="1" u="none" strike="noStrike" kern="1200" cap="none" spc="0" normalizeH="0" baseline="0" noProof="0" dirty="0">
+              <a:rPr kumimoji="0" lang="en-US" sz="1250" b="1" i="0" u="none" strike="noStrike" kern="1200" cap="none" spc="0" normalizeH="0" baseline="0" noProof="0" dirty="0">
                 <a:ln>
                   <a:noFill/>
                 </a:ln>
                 <a:solidFill>
-                  <a:srgbClr val="605E5C"/>
+                  <a:srgbClr val="8661C5"/>
                 </a:solidFill>
                 <a:effectLst/>
                 <a:uLnTx/>
@@ -21925,22 +21925,8 @@
                 <a:ea typeface="Segoe UI" pitchFamily="34" charset="-122"/>
                 <a:cs typeface="Segoe UI" pitchFamily="34" charset="-120"/>
               </a:rPr>
-              <a:t>+ planted wrong row</a:t>
+              <a:t>questions + policy context</a:t>
             </a:r>
-            <a:endParaRPr kumimoji="0" lang="en-US" sz="1250" b="0" i="0" u="none" strike="noStrike" kern="1200" cap="none" spc="0" normalizeH="0" baseline="0" noProof="0" dirty="0">
-              <a:ln>
-                <a:noFill/>
-              </a:ln>
-              <a:solidFill>
-                <a:prstClr val="black"/>
-              </a:solidFill>
-              <a:effectLst/>
-              <a:uLnTx/>
-              <a:uFillTx/>
-              <a:latin typeface="Calibri" panose="020F0502020204030204"/>
-              <a:ea typeface="+mn-ea"/>
-              <a:cs typeface="+mn-cs"/>
-            </a:endParaRPr>
           </a:p>
         </p:txBody>
       </p:sp>
@@ -22068,7 +22054,7 @@
                 <a:ea typeface="Segoe UI" pitchFamily="34" charset="-122"/>
                 <a:cs typeface="Segoe UI" pitchFamily="34" charset="-120"/>
               </a:rPr>
-              <a:t>Agent</a:t>
+              <a:t>Candidate</a:t>
             </a:r>
             <a:endParaRPr kumimoji="0" lang="en-US" sz="1250" b="0" i="0" u="none" strike="noStrike" kern="1200" cap="none" spc="0" normalizeH="0" baseline="0" noProof="0" dirty="0">
               <a:ln>
@@ -22084,6 +22070,42 @@
               <a:ea typeface="+mn-ea"/>
               <a:cs typeface="+mn-cs"/>
             </a:endParaRPr>
+          </a:p>
+          <a:p>
+            <a:pPr marL="0" marR="0" lvl="0" indent="0" algn="ctr" defTabSz="914400" rtl="0" eaLnBrk="1" fontAlgn="auto" latinLnBrk="0" hangingPunct="1">
+              <a:lnSpc>
+                <a:spcPct val="95000"/>
+              </a:lnSpc>
+              <a:spcBef>
+                <a:spcPts val="0"/>
+              </a:spcBef>
+              <a:spcAft>
+                <a:spcPts val="0"/>
+              </a:spcAft>
+              <a:buClrTx/>
+              <a:buSzTx/>
+              <a:buFontTx/>
+              <a:buNone/>
+              <a:tabLst/>
+              <a:defRPr/>
+            </a:pPr>
+            <a:r>
+              <a:rPr kumimoji="0" lang="en-US" sz="1250" b="1" i="0" u="none" strike="noStrike" kern="1200" cap="none" spc="0" normalizeH="0" baseline="0" noProof="0" dirty="0">
+                <a:ln>
+                  <a:noFill/>
+                </a:ln>
+                <a:solidFill>
+                  <a:srgbClr val="FFFFFF"/>
+                </a:solidFill>
+                <a:effectLst/>
+                <a:uLnTx/>
+                <a:uFillTx/>
+                <a:latin typeface="Segoe UI" pitchFamily="34" charset="0"/>
+                <a:ea typeface="Segoe UI" pitchFamily="34" charset="-122"/>
+                <a:cs typeface="Segoe UI" pitchFamily="34" charset="-120"/>
+              </a:rPr>
+              <a:t>prompt + model</a:t>
+            </a:r>
           </a:p>
         </p:txBody>
       </p:sp>
@@ -22247,12 +22269,12 @@
               <a:defRPr/>
             </a:pPr>
             <a:r>
-              <a:rPr kumimoji="0" lang="en-US" sz="950" b="0" i="1" u="none" strike="noStrike" kern="1200" cap="none" spc="0" normalizeH="0" baseline="0" noProof="0" dirty="0">
+              <a:rPr kumimoji="0" lang="en-US" sz="1250" b="1" i="0" u="none" strike="noStrike" kern="1200" cap="none" spc="0" normalizeH="0" baseline="0" noProof="0" dirty="0">
                 <a:ln>
                   <a:noFill/>
                 </a:ln>
                 <a:solidFill>
-                  <a:srgbClr val="E4F3FC"/>
+                  <a:srgbClr val="FFFFFF"/>
                 </a:solidFill>
                 <a:effectLst/>
                 <a:uLnTx/>
@@ -22261,22 +22283,8 @@
                 <a:ea typeface="Segoe UI" pitchFamily="34" charset="-122"/>
                 <a:cs typeface="Segoe UI" pitchFamily="34" charset="-120"/>
               </a:rPr>
-              <a:t>groundedness · tool-accuracy</a:t>
+              <a:t>groundedness · relevance · coherence</a:t>
             </a:r>
-            <a:endParaRPr kumimoji="0" lang="en-US" sz="1250" b="0" i="0" u="none" strike="noStrike" kern="1200" cap="none" spc="0" normalizeH="0" baseline="0" noProof="0" dirty="0">
-              <a:ln>
-                <a:noFill/>
-              </a:ln>
-              <a:solidFill>
-                <a:prstClr val="black"/>
-              </a:solidFill>
-              <a:effectLst/>
-              <a:uLnTx/>
-              <a:uFillTx/>
-              <a:latin typeface="Calibri" panose="020F0502020204030204"/>
-              <a:ea typeface="+mn-ea"/>
-              <a:cs typeface="+mn-cs"/>
-            </a:endParaRPr>
           </a:p>
         </p:txBody>
       </p:sp>
@@ -23458,7 +23466,7 @@
                 <a:ea typeface="Segoe UI" pitchFamily="34" charset="-122"/>
                 <a:cs typeface="Segoe UI" pitchFamily="34" charset="-120"/>
               </a:rPr>
-              <a:t>Scores locally + uploads to the Foundry Evaluations tab</a:t>
+              <a:t>Candidate answers are generated before cloud evaluation</a:t>
             </a:r>
             <a:endParaRPr kumimoji="0" lang="en-US" sz="1150" b="0" i="0" u="none" strike="noStrike" kern="1200" cap="none" spc="0" normalizeH="0" baseline="0" noProof="0" dirty="0">
               <a:ln>

</xml_diff>